<commit_message>
Point canonical/OG/sitemap/manifest and repo links at the deployed Pages URL; regenerate the deck with final links
</commit_message>
<xml_diff>
--- a/docs/ContribMatch-Pitch-Deck.pptx
+++ b/docs/ContribMatch-Pitch-Deck.pptx
@@ -4269,7 +4269,7 @@
                 </a:solidFill>
                 <a:latin typeface="Consolas"/>
               </a:rPr>
-              <a:t>git clone https://github.com/contribmatch/contribmatch</a:t>
+              <a:t>git clone https://github.com/Tanmay-Tiwaricyber/contribmatch</a:t>
             </a:r>
           </a:p>
           <a:p>
@@ -4493,7 +4493,7 @@
                 </a:solidFill>
                 <a:latin typeface="Calibri"/>
               </a:rPr>
-              <a:t>https://&lt;user&gt;.github.io/contribmatch/</a:t>
+              <a:t>https://tanmay-tiwaricyber.github.io/contribmatch/</a:t>
             </a:r>
           </a:p>
           <a:p>
@@ -4525,7 +4525,7 @@
                 </a:solidFill>
                 <a:latin typeface="Calibri"/>
               </a:rPr>
-              <a:t>https://github.com/&lt;user&gt;/contribmatch</a:t>
+              <a:t>https://github.com/Tanmay-Tiwaricyber/contribmatch</a:t>
             </a:r>
           </a:p>
           <a:p>
@@ -5302,7 +5302,7 @@
                 </a:solidFill>
                 <a:latin typeface="Consolas"/>
               </a:rPr>
-              <a:t>Live: https://&lt;user&gt;.github.io/contribmatch/   ·   Code: https://github.com/&lt;user&gt;/contribmatch   ·   Demo: [video link]</a:t>
+              <a:t>Live: https://tanmay-tiwaricyber.github.io/contribmatch/   ·   Code: https://github.com/Tanmay-Tiwaricyber/contribmatch   ·   Demo: [video link]</a:t>
             </a:r>
           </a:p>
           <a:p>

</xml_diff>

<commit_message>
Deck slide 12: frame the five facts as deliberate design decisions, not limitations
</commit_message>
<xml_diff>
--- a/docs/ContribMatch-Pitch-Deck.pptx
+++ b/docs/ContribMatch-Pitch-Deck.pptx
@@ -4743,7 +4743,7 @@
                 </a:solidFill>
                 <a:latin typeface="Calibri"/>
               </a:rPr>
-              <a:t>What is honest about its limits</a:t>
+              <a:t>By design, not by accident</a:t>
             </a:r>
           </a:p>
         </p:txBody>
@@ -4756,25 +4756,602 @@
         </p:nvSpPr>
         <p:spPr>
           <a:xfrm>
-            <a:off x="502920" y="1737360"/>
-            <a:ext cx="5852160" cy="4389120"/>
-          </a:xfrm>
-          <a:prstGeom prst="rect">
-            <a:avLst/>
-          </a:prstGeom>
-          <a:noFill/>
-        </p:spPr>
-        <p:txBody>
-          <a:bodyPr wrap="square">
-            <a:spAutoFit/>
-          </a:bodyPr>
-          <a:lstStyle/>
-          <a:p/>
-        </p:txBody>
-      </p:sp>
-      <p:sp>
-        <p:nvSpPr>
-          <p:cNvPr id="4" name="Rectangle 3"/>
+            <a:off x="502920" y="960120"/>
+            <a:ext cx="10515600" cy="548640"/>
+          </a:xfrm>
+          <a:prstGeom prst="rect">
+            <a:avLst/>
+          </a:prstGeom>
+          <a:noFill/>
+        </p:spPr>
+        <p:txBody>
+          <a:bodyPr wrap="square">
+            <a:spAutoFit/>
+          </a:bodyPr>
+          <a:lstStyle/>
+          <a:p>
+            <a:pPr algn="l">
+              <a:spcAft>
+                <a:spcPts val="600"/>
+              </a:spcAft>
+            </a:pPr>
+            <a:r>
+              <a:rPr sz="1500" b="0">
+                <a:solidFill>
+                  <a:srgbClr val="666667"/>
+                </a:solidFill>
+                <a:latin typeface="Calibri"/>
+              </a:rPr>
+              <a:t>Five decisions that shape the product. Ask us about any of them.</a:t>
+            </a:r>
+          </a:p>
+        </p:txBody>
+      </p:sp>
+      <p:sp>
+        <p:nvSpPr>
+          <p:cNvPr id="4" name="TextBox 3"/>
+          <p:cNvSpPr txBox="1"/>
+          <p:nvPr/>
+        </p:nvSpPr>
+        <p:spPr>
+          <a:xfrm>
+            <a:off x="502920" y="1892807"/>
+            <a:ext cx="822960" cy="548640"/>
+          </a:xfrm>
+          <a:prstGeom prst="rect">
+            <a:avLst/>
+          </a:prstGeom>
+          <a:noFill/>
+        </p:spPr>
+        <p:txBody>
+          <a:bodyPr wrap="square">
+            <a:spAutoFit/>
+          </a:bodyPr>
+          <a:lstStyle/>
+          <a:p>
+            <a:pPr algn="l">
+              <a:spcAft>
+                <a:spcPts val="600"/>
+              </a:spcAft>
+            </a:pPr>
+            <a:r>
+              <a:rPr sz="2600" b="1">
+                <a:solidFill>
+                  <a:srgbClr val="666667"/>
+                </a:solidFill>
+                <a:latin typeface="Consolas"/>
+              </a:rPr>
+              <a:t>01</a:t>
+            </a:r>
+          </a:p>
+        </p:txBody>
+      </p:sp>
+      <p:sp>
+        <p:nvSpPr>
+          <p:cNvPr id="5" name="TextBox 4"/>
+          <p:cNvSpPr txBox="1"/>
+          <p:nvPr/>
+        </p:nvSpPr>
+        <p:spPr>
+          <a:xfrm>
+            <a:off x="1600200" y="1947672"/>
+            <a:ext cx="9966960" cy="640080"/>
+          </a:xfrm>
+          <a:prstGeom prst="rect">
+            <a:avLst/>
+          </a:prstGeom>
+          <a:noFill/>
+        </p:spPr>
+        <p:txBody>
+          <a:bodyPr wrap="square">
+            <a:spAutoFit/>
+          </a:bodyPr>
+          <a:lstStyle/>
+          <a:p>
+            <a:pPr algn="l">
+              <a:spcAft>
+                <a:spcPts val="600"/>
+              </a:spcAft>
+            </a:pPr>
+            <a:r>
+              <a:rPr sz="1500" b="0">
+                <a:solidFill>
+                  <a:srgbClr val="101014"/>
+                </a:solidFill>
+                <a:latin typeface="Calibri"/>
+              </a:rPr>
+              <a:t>The ranking is a rubric — every score traces to rules you can read, not a black-box guess.</a:t>
+            </a:r>
+          </a:p>
+        </p:txBody>
+      </p:sp>
+      <p:sp>
+        <p:nvSpPr>
+          <p:cNvPr id="6" name="Rectangle 5"/>
+          <p:cNvSpPr/>
+          <p:nvPr/>
+        </p:nvSpPr>
+        <p:spPr>
+          <a:xfrm>
+            <a:off x="1600200" y="2624327"/>
+            <a:ext cx="9966960" cy="13716"/>
+          </a:xfrm>
+          <a:prstGeom prst="rect">
+            <a:avLst/>
+          </a:prstGeom>
+          <a:solidFill>
+            <a:srgbClr val="D8D6D2"/>
+          </a:solidFill>
+          <a:ln>
+            <a:noFill/>
+          </a:ln>
+        </p:spPr>
+        <p:style>
+          <a:lnRef idx="1">
+            <a:schemeClr val="accent1"/>
+          </a:lnRef>
+          <a:fillRef idx="3">
+            <a:schemeClr val="accent1"/>
+          </a:fillRef>
+          <a:effectRef idx="2">
+            <a:schemeClr val="accent1"/>
+          </a:effectRef>
+          <a:fontRef idx="minor">
+            <a:schemeClr val="lt1"/>
+          </a:fontRef>
+        </p:style>
+        <p:txBody>
+          <a:bodyPr rtlCol="0" anchor="ctr"/>
+          <a:lstStyle/>
+          <a:p>
+            <a:pPr algn="ctr"/>
+          </a:p>
+        </p:txBody>
+      </p:sp>
+      <p:sp>
+        <p:nvSpPr>
+          <p:cNvPr id="7" name="TextBox 6"/>
+          <p:cNvSpPr txBox="1"/>
+          <p:nvPr/>
+        </p:nvSpPr>
+        <p:spPr>
+          <a:xfrm>
+            <a:off x="502920" y="2752344"/>
+            <a:ext cx="822960" cy="548640"/>
+          </a:xfrm>
+          <a:prstGeom prst="rect">
+            <a:avLst/>
+          </a:prstGeom>
+          <a:noFill/>
+        </p:spPr>
+        <p:txBody>
+          <a:bodyPr wrap="square">
+            <a:spAutoFit/>
+          </a:bodyPr>
+          <a:lstStyle/>
+          <a:p>
+            <a:pPr algn="l">
+              <a:spcAft>
+                <a:spcPts val="600"/>
+              </a:spcAft>
+            </a:pPr>
+            <a:r>
+              <a:rPr sz="2600" b="1">
+                <a:solidFill>
+                  <a:srgbClr val="666667"/>
+                </a:solidFill>
+                <a:latin typeface="Consolas"/>
+              </a:rPr>
+              <a:t>02</a:t>
+            </a:r>
+          </a:p>
+        </p:txBody>
+      </p:sp>
+      <p:sp>
+        <p:nvSpPr>
+          <p:cNvPr id="8" name="TextBox 7"/>
+          <p:cNvSpPr txBox="1"/>
+          <p:nvPr/>
+        </p:nvSpPr>
+        <p:spPr>
+          <a:xfrm>
+            <a:off x="1600200" y="2807208"/>
+            <a:ext cx="9966960" cy="640080"/>
+          </a:xfrm>
+          <a:prstGeom prst="rect">
+            <a:avLst/>
+          </a:prstGeom>
+          <a:noFill/>
+        </p:spPr>
+        <p:txBody>
+          <a:bodyPr wrap="square">
+            <a:spAutoFit/>
+          </a:bodyPr>
+          <a:lstStyle/>
+          <a:p>
+            <a:pPr algn="l">
+              <a:spcAft>
+                <a:spcPts val="600"/>
+              </a:spcAft>
+            </a:pPr>
+            <a:r>
+              <a:rPr sz="1500" b="0">
+                <a:solidFill>
+                  <a:srgbClr val="101014"/>
+                </a:solidFill>
+                <a:latin typeface="Calibri"/>
+              </a:rPr>
+              <a:t>Gemma refines and writes; the rules decide. Turn the model off and you still get a shortlist and a plan.</a:t>
+            </a:r>
+          </a:p>
+        </p:txBody>
+      </p:sp>
+      <p:sp>
+        <p:nvSpPr>
+          <p:cNvPr id="9" name="Rectangle 8"/>
+          <p:cNvSpPr/>
+          <p:nvPr/>
+        </p:nvSpPr>
+        <p:spPr>
+          <a:xfrm>
+            <a:off x="1600200" y="3483863"/>
+            <a:ext cx="9966960" cy="13716"/>
+          </a:xfrm>
+          <a:prstGeom prst="rect">
+            <a:avLst/>
+          </a:prstGeom>
+          <a:solidFill>
+            <a:srgbClr val="D8D6D2"/>
+          </a:solidFill>
+          <a:ln>
+            <a:noFill/>
+          </a:ln>
+        </p:spPr>
+        <p:style>
+          <a:lnRef idx="1">
+            <a:schemeClr val="accent1"/>
+          </a:lnRef>
+          <a:fillRef idx="3">
+            <a:schemeClr val="accent1"/>
+          </a:fillRef>
+          <a:effectRef idx="2">
+            <a:schemeClr val="accent1"/>
+          </a:effectRef>
+          <a:fontRef idx="minor">
+            <a:schemeClr val="lt1"/>
+          </a:fontRef>
+        </p:style>
+        <p:txBody>
+          <a:bodyPr rtlCol="0" anchor="ctr"/>
+          <a:lstStyle/>
+          <a:p>
+            <a:pPr algn="ctr"/>
+          </a:p>
+        </p:txBody>
+      </p:sp>
+      <p:sp>
+        <p:nvSpPr>
+          <p:cNvPr id="10" name="TextBox 9"/>
+          <p:cNvSpPr txBox="1"/>
+          <p:nvPr/>
+        </p:nvSpPr>
+        <p:spPr>
+          <a:xfrm>
+            <a:off x="502920" y="3611879"/>
+            <a:ext cx="822960" cy="548640"/>
+          </a:xfrm>
+          <a:prstGeom prst="rect">
+            <a:avLst/>
+          </a:prstGeom>
+          <a:noFill/>
+        </p:spPr>
+        <p:txBody>
+          <a:bodyPr wrap="square">
+            <a:spAutoFit/>
+          </a:bodyPr>
+          <a:lstStyle/>
+          <a:p>
+            <a:pPr algn="l">
+              <a:spcAft>
+                <a:spcPts val="600"/>
+              </a:spcAft>
+            </a:pPr>
+            <a:r>
+              <a:rPr sz="2600" b="1">
+                <a:solidFill>
+                  <a:srgbClr val="666667"/>
+                </a:solidFill>
+                <a:latin typeface="Consolas"/>
+              </a:rPr>
+              <a:t>03</a:t>
+            </a:r>
+          </a:p>
+        </p:txBody>
+      </p:sp>
+      <p:sp>
+        <p:nvSpPr>
+          <p:cNvPr id="11" name="TextBox 10"/>
+          <p:cNvSpPr txBox="1"/>
+          <p:nvPr/>
+        </p:nvSpPr>
+        <p:spPr>
+          <a:xfrm>
+            <a:off x="1600200" y="3666744"/>
+            <a:ext cx="9966960" cy="640080"/>
+          </a:xfrm>
+          <a:prstGeom prst="rect">
+            <a:avLst/>
+          </a:prstGeom>
+          <a:noFill/>
+        </p:spPr>
+        <p:txBody>
+          <a:bodyPr wrap="square">
+            <a:spAutoFit/>
+          </a:bodyPr>
+          <a:lstStyle/>
+          <a:p>
+            <a:pPr algn="l">
+              <a:spcAft>
+                <a:spcPts val="600"/>
+              </a:spcAft>
+            </a:pPr>
+            <a:r>
+              <a:rPr sz="1500" b="0">
+                <a:solidFill>
+                  <a:srgbClr val="101014"/>
+                </a:solidFill>
+                <a:latin typeface="Calibri"/>
+              </a:rPr>
+              <a:t>The graph always says what it covers — a token unlocks the exact year; without one you get 90 days of public events, clearly labelled.</a:t>
+            </a:r>
+          </a:p>
+        </p:txBody>
+      </p:sp>
+      <p:sp>
+        <p:nvSpPr>
+          <p:cNvPr id="12" name="Rectangle 11"/>
+          <p:cNvSpPr/>
+          <p:nvPr/>
+        </p:nvSpPr>
+        <p:spPr>
+          <a:xfrm>
+            <a:off x="1600200" y="4343400"/>
+            <a:ext cx="9966960" cy="13716"/>
+          </a:xfrm>
+          <a:prstGeom prst="rect">
+            <a:avLst/>
+          </a:prstGeom>
+          <a:solidFill>
+            <a:srgbClr val="D8D6D2"/>
+          </a:solidFill>
+          <a:ln>
+            <a:noFill/>
+          </a:ln>
+        </p:spPr>
+        <p:style>
+          <a:lnRef idx="1">
+            <a:schemeClr val="accent1"/>
+          </a:lnRef>
+          <a:fillRef idx="3">
+            <a:schemeClr val="accent1"/>
+          </a:fillRef>
+          <a:effectRef idx="2">
+            <a:schemeClr val="accent1"/>
+          </a:effectRef>
+          <a:fontRef idx="minor">
+            <a:schemeClr val="lt1"/>
+          </a:fontRef>
+        </p:style>
+        <p:txBody>
+          <a:bodyPr rtlCol="0" anchor="ctr"/>
+          <a:lstStyle/>
+          <a:p>
+            <a:pPr algn="ctr"/>
+          </a:p>
+        </p:txBody>
+      </p:sp>
+      <p:sp>
+        <p:nvSpPr>
+          <p:cNvPr id="13" name="TextBox 12"/>
+          <p:cNvSpPr txBox="1"/>
+          <p:nvPr/>
+        </p:nvSpPr>
+        <p:spPr>
+          <a:xfrm>
+            <a:off x="502920" y="4471415"/>
+            <a:ext cx="822960" cy="548640"/>
+          </a:xfrm>
+          <a:prstGeom prst="rect">
+            <a:avLst/>
+          </a:prstGeom>
+          <a:noFill/>
+        </p:spPr>
+        <p:txBody>
+          <a:bodyPr wrap="square">
+            <a:spAutoFit/>
+          </a:bodyPr>
+          <a:lstStyle/>
+          <a:p>
+            <a:pPr algn="l">
+              <a:spcAft>
+                <a:spcPts val="600"/>
+              </a:spcAft>
+            </a:pPr>
+            <a:r>
+              <a:rPr sz="2600" b="1">
+                <a:solidFill>
+                  <a:srgbClr val="666667"/>
+                </a:solidFill>
+                <a:latin typeface="Consolas"/>
+              </a:rPr>
+              <a:t>04</a:t>
+            </a:r>
+          </a:p>
+        </p:txBody>
+      </p:sp>
+      <p:sp>
+        <p:nvSpPr>
+          <p:cNvPr id="14" name="TextBox 13"/>
+          <p:cNvSpPr txBox="1"/>
+          <p:nvPr/>
+        </p:nvSpPr>
+        <p:spPr>
+          <a:xfrm>
+            <a:off x="1600200" y="4526279"/>
+            <a:ext cx="9966960" cy="640080"/>
+          </a:xfrm>
+          <a:prstGeom prst="rect">
+            <a:avLst/>
+          </a:prstGeom>
+          <a:noFill/>
+        </p:spPr>
+        <p:txBody>
+          <a:bodyPr wrap="square">
+            <a:spAutoFit/>
+          </a:bodyPr>
+          <a:lstStyle/>
+          <a:p>
+            <a:pPr algn="l">
+              <a:spcAft>
+                <a:spcPts val="600"/>
+              </a:spcAft>
+            </a:pPr>
+            <a:r>
+              <a:rPr sz="1500" b="0">
+                <a:solidFill>
+                  <a:srgbClr val="101014"/>
+                </a:solidFill>
+                <a:latin typeface="Calibri"/>
+              </a:rPr>
+              <a:t>Results are bounded by GitHub's own search index. Nothing is invented, and the static catalogue keeps good data flowing.</a:t>
+            </a:r>
+          </a:p>
+        </p:txBody>
+      </p:sp>
+      <p:sp>
+        <p:nvSpPr>
+          <p:cNvPr id="15" name="Rectangle 14"/>
+          <p:cNvSpPr/>
+          <p:nvPr/>
+        </p:nvSpPr>
+        <p:spPr>
+          <a:xfrm>
+            <a:off x="1600200" y="5202936"/>
+            <a:ext cx="9966960" cy="13716"/>
+          </a:xfrm>
+          <a:prstGeom prst="rect">
+            <a:avLst/>
+          </a:prstGeom>
+          <a:solidFill>
+            <a:srgbClr val="D8D6D2"/>
+          </a:solidFill>
+          <a:ln>
+            <a:noFill/>
+          </a:ln>
+        </p:spPr>
+        <p:style>
+          <a:lnRef idx="1">
+            <a:schemeClr val="accent1"/>
+          </a:lnRef>
+          <a:fillRef idx="3">
+            <a:schemeClr val="accent1"/>
+          </a:fillRef>
+          <a:effectRef idx="2">
+            <a:schemeClr val="accent1"/>
+          </a:effectRef>
+          <a:fontRef idx="minor">
+            <a:schemeClr val="lt1"/>
+          </a:fontRef>
+        </p:style>
+        <p:txBody>
+          <a:bodyPr rtlCol="0" anchor="ctr"/>
+          <a:lstStyle/>
+          <a:p>
+            <a:pPr algn="ctr"/>
+          </a:p>
+        </p:txBody>
+      </p:sp>
+      <p:sp>
+        <p:nvSpPr>
+          <p:cNvPr id="16" name="TextBox 15"/>
+          <p:cNvSpPr txBox="1"/>
+          <p:nvPr/>
+        </p:nvSpPr>
+        <p:spPr>
+          <a:xfrm>
+            <a:off x="502920" y="5330951"/>
+            <a:ext cx="822960" cy="548640"/>
+          </a:xfrm>
+          <a:prstGeom prst="rect">
+            <a:avLst/>
+          </a:prstGeom>
+          <a:noFill/>
+        </p:spPr>
+        <p:txBody>
+          <a:bodyPr wrap="square">
+            <a:spAutoFit/>
+          </a:bodyPr>
+          <a:lstStyle/>
+          <a:p>
+            <a:pPr algn="l">
+              <a:spcAft>
+                <a:spcPts val="600"/>
+              </a:spcAft>
+            </a:pPr>
+            <a:r>
+              <a:rPr sz="2600" b="1">
+                <a:solidFill>
+                  <a:srgbClr val="666667"/>
+                </a:solidFill>
+                <a:latin typeface="Consolas"/>
+              </a:rPr>
+              <a:t>05</a:t>
+            </a:r>
+          </a:p>
+        </p:txBody>
+      </p:sp>
+      <p:sp>
+        <p:nvSpPr>
+          <p:cNvPr id="17" name="TextBox 16"/>
+          <p:cNvSpPr txBox="1"/>
+          <p:nvPr/>
+        </p:nvSpPr>
+        <p:spPr>
+          <a:xfrm>
+            <a:off x="1600200" y="5385815"/>
+            <a:ext cx="9966960" cy="640080"/>
+          </a:xfrm>
+          <a:prstGeom prst="rect">
+            <a:avLst/>
+          </a:prstGeom>
+          <a:noFill/>
+        </p:spPr>
+        <p:txBody>
+          <a:bodyPr wrap="square">
+            <a:spAutoFit/>
+          </a:bodyPr>
+          <a:lstStyle/>
+          <a:p>
+            <a:pPr algn="l">
+              <a:spcAft>
+                <a:spcPts val="600"/>
+              </a:spcAft>
+            </a:pPr>
+            <a:r>
+              <a:rPr sz="1500" b="0">
+                <a:solidFill>
+                  <a:srgbClr val="101014"/>
+                </a:solidFill>
+                <a:latin typeface="Calibri"/>
+              </a:rPr>
+              <a:t>No backend and no write path: nothing is ever posted on your behalf. Every action stays yours.</a:t>
+            </a:r>
+          </a:p>
+        </p:txBody>
+      </p:sp>
+      <p:sp>
+        <p:nvSpPr>
+          <p:cNvPr id="18" name="Rectangle 17"/>
           <p:cNvSpPr/>
           <p:nvPr/>
         </p:nvSpPr>
@@ -4817,7 +5394,7 @@
       </p:sp>
       <p:sp>
         <p:nvSpPr>
-          <p:cNvPr id="5" name="TextBox 4"/>
+          <p:cNvPr id="19" name="TextBox 18"/>
           <p:cNvSpPr txBox="1"/>
           <p:nvPr/>
         </p:nvSpPr>
@@ -4849,238 +5426,14 @@
                 </a:solidFill>
                 <a:latin typeface="Consolas"/>
               </a:rPr>
-              <a:t>limits</a:t>
-            </a:r>
-          </a:p>
-        </p:txBody>
-      </p:sp>
-      <p:sp>
-        <p:nvSpPr>
-          <p:cNvPr id="6" name="TextBox 5"/>
-          <p:cNvSpPr txBox="1"/>
-          <p:nvPr/>
-        </p:nvSpPr>
-        <p:spPr>
-          <a:xfrm>
-            <a:off x="11064240" y="6355080"/>
-            <a:ext cx="731520" cy="365760"/>
-          </a:xfrm>
-          <a:prstGeom prst="rect">
-            <a:avLst/>
-          </a:prstGeom>
-          <a:noFill/>
-        </p:spPr>
-        <p:txBody>
-          <a:bodyPr wrap="square">
-            <a:spAutoFit/>
-          </a:bodyPr>
-          <a:lstStyle/>
-          <a:p>
-            <a:pPr algn="r">
-              <a:spcAft>
-                <a:spcPts val="600"/>
-              </a:spcAft>
-            </a:pPr>
-            <a:r>
-              <a:rPr sz="1000" b="0">
-                <a:solidFill>
-                  <a:srgbClr val="666667"/>
-                </a:solidFill>
-                <a:latin typeface="Consolas"/>
-              </a:rPr>
-              <a:t>12</a:t>
-            </a:r>
-          </a:p>
-        </p:txBody>
-      </p:sp>
-      <p:sp>
-        <p:nvSpPr>
-          <p:cNvPr id="7" name="TextBox 6"/>
-          <p:cNvSpPr txBox="1"/>
-          <p:nvPr/>
-        </p:nvSpPr>
-        <p:spPr>
-          <a:xfrm>
-            <a:off x="502920" y="1737360"/>
-            <a:ext cx="10058400" cy="4389120"/>
-          </a:xfrm>
-          <a:prstGeom prst="rect">
-            <a:avLst/>
-          </a:prstGeom>
-          <a:noFill/>
-        </p:spPr>
-        <p:txBody>
-          <a:bodyPr wrap="square">
-            <a:spAutoFit/>
-          </a:bodyPr>
-          <a:lstStyle/>
-          <a:p>
-            <a:pPr algn="l">
-              <a:spcAft>
-                <a:spcPts val="600"/>
-              </a:spcAft>
-            </a:pPr>
-            <a:r>
-              <a:rPr sz="1900" b="0">
-                <a:solidFill>
-                  <a:srgbClr val="101014"/>
-                </a:solidFill>
-                <a:latin typeface="Calibri"/>
-              </a:rPr>
-              <a:t>•  The ranking is a rubric, not a prediction of success.</a:t>
-            </a:r>
-          </a:p>
-          <a:p>
-            <a:pPr algn="l">
-              <a:spcAft>
-                <a:spcPts val="600"/>
-              </a:spcAft>
-            </a:pPr>
-            <a:r>
-              <a:rPr sz="1900" b="0">
-                <a:solidFill>
-                  <a:srgbClr val="101014"/>
-                </a:solidFill>
-                <a:latin typeface="Calibri"/>
-              </a:rPr>
-              <a:t>•  The model writes the notes; it does not decide the match.</a:t>
-            </a:r>
-          </a:p>
-          <a:p>
-            <a:pPr algn="l">
-              <a:spcAft>
-                <a:spcPts val="600"/>
-              </a:spcAft>
-            </a:pPr>
-            <a:r>
-              <a:rPr sz="1900" b="0">
-                <a:solidFill>
-                  <a:srgbClr val="101014"/>
-                </a:solidFill>
-                <a:latin typeface="Calibri"/>
-              </a:rPr>
-              <a:t>•  Without a token the graph is three months, not a year.</a:t>
-            </a:r>
-          </a:p>
-          <a:p>
-            <a:pPr algn="l">
-              <a:spcAft>
-                <a:spcPts val="600"/>
-              </a:spcAft>
-            </a:pPr>
-            <a:r>
-              <a:rPr sz="1900" b="0">
-                <a:solidFill>
-                  <a:srgbClr val="101014"/>
-                </a:solidFill>
-                <a:latin typeface="Calibri"/>
-              </a:rPr>
-              <a:t>•  The search only sees what GitHub's search index sees.</a:t>
-            </a:r>
-          </a:p>
-          <a:p>
-            <a:pPr algn="l">
-              <a:spcAft>
-                <a:spcPts val="600"/>
-              </a:spcAft>
-            </a:pPr>
-            <a:r>
-              <a:rPr sz="1900" b="0">
-                <a:solidFill>
-                  <a:srgbClr val="101014"/>
-                </a:solidFill>
-                <a:latin typeface="Calibri"/>
-              </a:rPr>
-              <a:t>•  It is a static site, which means it cannot do anything on your behalf — and that is on purpose.</a:t>
-            </a:r>
-          </a:p>
-        </p:txBody>
-      </p:sp>
-      <p:sp>
-        <p:nvSpPr>
-          <p:cNvPr id="8" name="Rectangle 7"/>
-          <p:cNvSpPr/>
-          <p:nvPr/>
-        </p:nvSpPr>
-        <p:spPr>
-          <a:xfrm>
-            <a:off x="0" y="0"/>
-            <a:ext cx="12191695" cy="54864"/>
-          </a:xfrm>
-          <a:prstGeom prst="rect">
-            <a:avLst/>
-          </a:prstGeom>
-          <a:solidFill>
-            <a:srgbClr val="2D81FF"/>
-          </a:solidFill>
-          <a:ln>
-            <a:noFill/>
-          </a:ln>
-        </p:spPr>
-        <p:style>
-          <a:lnRef idx="1">
-            <a:schemeClr val="accent1"/>
-          </a:lnRef>
-          <a:fillRef idx="3">
-            <a:schemeClr val="accent1"/>
-          </a:fillRef>
-          <a:effectRef idx="2">
-            <a:schemeClr val="accent1"/>
-          </a:effectRef>
-          <a:fontRef idx="minor">
-            <a:schemeClr val="lt1"/>
-          </a:fontRef>
-        </p:style>
-        <p:txBody>
-          <a:bodyPr rtlCol="0" anchor="ctr"/>
-          <a:lstStyle/>
-          <a:p>
-            <a:pPr algn="ctr"/>
-          </a:p>
-        </p:txBody>
-      </p:sp>
-      <p:sp>
-        <p:nvSpPr>
-          <p:cNvPr id="9" name="TextBox 8"/>
-          <p:cNvSpPr txBox="1"/>
-          <p:nvPr/>
-        </p:nvSpPr>
-        <p:spPr>
-          <a:xfrm>
-            <a:off x="502920" y="6355080"/>
-            <a:ext cx="7315200" cy="365760"/>
-          </a:xfrm>
-          <a:prstGeom prst="rect">
-            <a:avLst/>
-          </a:prstGeom>
-          <a:noFill/>
-        </p:spPr>
-        <p:txBody>
-          <a:bodyPr wrap="square">
-            <a:spAutoFit/>
-          </a:bodyPr>
-          <a:lstStyle/>
-          <a:p>
-            <a:pPr algn="l">
-              <a:spcAft>
-                <a:spcPts val="600"/>
-              </a:spcAft>
-            </a:pPr>
-            <a:r>
-              <a:rPr sz="1000" b="0">
-                <a:solidFill>
-                  <a:srgbClr val="666667"/>
-                </a:solidFill>
-                <a:latin typeface="Consolas"/>
-              </a:rPr>
-              <a:t>limits</a:t>
-            </a:r>
-          </a:p>
-        </p:txBody>
-      </p:sp>
-      <p:sp>
-        <p:nvSpPr>
-          <p:cNvPr id="10" name="TextBox 9"/>
+              <a:t>design decisions</a:t>
+            </a:r>
+          </a:p>
+        </p:txBody>
+      </p:sp>
+      <p:sp>
+        <p:nvSpPr>
+          <p:cNvPr id="20" name="TextBox 19"/>
           <p:cNvSpPr txBox="1"/>
           <p:nvPr/>
         </p:nvSpPr>

</xml_diff>

<commit_message>
Widen the no-token graph: a full year of public issues and pull requests via the search API, merged behind the 90-day event detail
</commit_message>
<xml_diff>
--- a/docs/ContribMatch-Pitch-Deck.pptx
+++ b/docs/ContribMatch-Pitch-Deck.pptx
@@ -5102,7 +5102,7 @@
                 </a:solidFill>
                 <a:latin typeface="Calibri"/>
               </a:rPr>
-              <a:t>The graph always says what it covers — a token unlocks the exact year; without one you get 90 days of public events, clearly labelled.</a:t>
+              <a:t>The graph always says what it covers — a token unlocks the exact calendar; without one you still get a full year of public issues and pull requests, clearly labelled.</a:t>
             </a:r>
           </a:p>
         </p:txBody>
@@ -11137,7 +11137,7 @@
                 </a:solidFill>
                 <a:latin typeface="Calibri"/>
               </a:rPr>
-              <a:t>about 90 days of public events, mapped</a:t>
+              <a:t>a full year of public issues + pull requests (search API), 90 days of event detail</a:t>
             </a:r>
           </a:p>
         </p:txBody>

</xml_diff>